<commit_message>
Final cleanup: presentation-ready tables, figures and README
</commit_message>
<xml_diff>
--- a/presentation/ML_MiniProject.pptx
+++ b/presentation/ML_MiniProject.pptx
@@ -929,7 +929,7 @@
           <a:lstStyle/>
           <a:p>
             <a:r>
-              <a:t>This chart puts every model on one accuracy against training-time plot, with a log time axis, one panel per class size. The table gives the best model of each family. At 50 classes the CNN leads with 81.2 percent in 431.4 seconds, while tuned XGBoost reaches 78.0 in 7,191.1 seconds. Transfer learning is the most accurate at 3 classes. Logistic regression is the fastest but falls off quickly as classes increase, and the SVMs sit between it and the CNNs.</a:t>
+              <a:t>This chart puts every model on one accuracy against training-time plot, with a log time axis, one panel per class size. The table gives the best model of each family. At 50 classes the CNN leads with 81.2 percent in 431 seconds, while tuned XGBoost reaches 78.0 in 7,191 seconds. Transfer learning is the most accurate at 3 classes. Logistic regression is the fastest but falls off quickly as classes increase, and the SVMs sit between it and the CNNs.</a:t>
             </a:r>
           </a:p>
         </p:txBody>
@@ -4176,7 +4176,7 @@
       </p:sp>
       <p:pic>
         <p:nvPicPr>
-          <p:cNvPr id="5" name="Picture 4" descr="samples_10x5.png"/>
+          <p:cNvPr id="5" name="Picture 4" descr="sample_drawings_10_classes.png"/>
           <p:cNvPicPr>
             <a:picLocks noChangeAspect="1"/>
           </p:cNvPicPr>
@@ -7100,7 +7100,7 @@
       </p:sp>
       <p:pic>
         <p:nvPicPr>
-          <p:cNvPr id="3" name="Picture 2" descr="tl_batchnorm.png"/>
+          <p:cNvPr id="3" name="Picture 2" descr="transfer_learning_batchnorm.png"/>
           <p:cNvPicPr>
             <a:picLocks noChangeAspect="1"/>
           </p:cNvPicPr>
@@ -7114,8 +7114,8 @@
         </p:blipFill>
         <p:spPr>
           <a:xfrm>
-            <a:off x="548640" y="1587979"/>
-            <a:ext cx="6766560" cy="4230680"/>
+            <a:off x="548640" y="1365082"/>
+            <a:ext cx="6766560" cy="4676475"/>
           </a:xfrm>
           <a:prstGeom prst="rect">
             <a:avLst/>
@@ -7780,7 +7780,7 @@
       </p:sp>
       <p:pic>
         <p:nvPicPr>
-          <p:cNvPr id="13" name="Picture 12" descr="xgb50_capped_vs_converged_curve.png"/>
+          <p:cNvPr id="13" name="Picture 12" descr="xgboost_50_classes_capped_vs_converged.png"/>
           <p:cNvPicPr>
             <a:picLocks noChangeAspect="1"/>
           </p:cNvPicPr>
@@ -8026,7 +8026,7 @@
       </p:sp>
       <p:pic>
         <p:nvPicPr>
-          <p:cNvPr id="3" name="Picture 2" descr="accuracy_vs_time.png"/>
+          <p:cNvPr id="3" name="Picture 2" descr="accuracy_vs_training_time.png"/>
           <p:cNvPicPr>
             <a:picLocks noChangeAspect="1"/>
           </p:cNvPicPr>
@@ -8180,7 +8180,7 @@
                           </a:solidFill>
                           <a:latin typeface="Arial"/>
                         </a:rPr>
-                        <a:t>TL (ResNet50)</a:t>
+                        <a:t>TL (VGG19)</a:t>
                       </a:r>
                     </a:p>
                   </a:txBody>
@@ -8251,7 +8251,7 @@
                           </a:solidFill>
                           <a:latin typeface="Arial"/>
                         </a:rPr>
-                        <a:t>79.3% · 19.9 s</a:t>
+                        <a:t>79.3% · 20 s</a:t>
                       </a:r>
                     </a:p>
                   </a:txBody>
@@ -8274,7 +8274,7 @@
                           </a:solidFill>
                           <a:latin typeface="Arial"/>
                         </a:rPr>
-                        <a:t>84.0% · 41.4 s</a:t>
+                        <a:t>84.0% · 41 s</a:t>
                       </a:r>
                     </a:p>
                   </a:txBody>
@@ -8297,7 +8297,7 @@
                           </a:solidFill>
                           <a:latin typeface="Arial"/>
                         </a:rPr>
-                        <a:t>91.7% · 37.7 s</a:t>
+                        <a:t>91.7% · 38 s</a:t>
                       </a:r>
                     </a:p>
                   </a:txBody>
@@ -8320,7 +8320,7 @@
                           </a:solidFill>
                           <a:latin typeface="Arial"/>
                         </a:rPr>
-                        <a:t>95.4% · 169.8 s</a:t>
+                        <a:t>95.4% · 207 s</a:t>
                       </a:r>
                     </a:p>
                   </a:txBody>
@@ -8343,7 +8343,7 @@
                           </a:solidFill>
                           <a:latin typeface="Arial"/>
                         </a:rPr>
-                        <a:t>91.7% · 56.8 s</a:t>
+                        <a:t>91.7% · 57 s</a:t>
                       </a:r>
                     </a:p>
                   </a:txBody>
@@ -8391,7 +8391,7 @@
                           </a:solidFill>
                           <a:latin typeface="Arial"/>
                         </a:rPr>
-                        <a:t>65.8% · 20.0 s</a:t>
+                        <a:t>65.8% · 20 s</a:t>
                       </a:r>
                     </a:p>
                   </a:txBody>
@@ -8414,7 +8414,7 @@
                           </a:solidFill>
                           <a:latin typeface="Arial"/>
                         </a:rPr>
-                        <a:t>74.6% · 655.3 s</a:t>
+                        <a:t>74.6% · 655 s</a:t>
                       </a:r>
                     </a:p>
                   </a:txBody>
@@ -8437,7 +8437,7 @@
                           </a:solidFill>
                           <a:latin typeface="Arial"/>
                         </a:rPr>
-                        <a:t>88.8% · 109.2 s</a:t>
+                        <a:t>88.8% · 109 s</a:t>
                       </a:r>
                     </a:p>
                   </a:txBody>
@@ -8483,7 +8483,7 @@
                           </a:solidFill>
                           <a:latin typeface="Arial"/>
                         </a:rPr>
-                        <a:t>89.8% · 485.8 s</a:t>
+                        <a:t>89.8% · 486 s</a:t>
                       </a:r>
                     </a:p>
                   </a:txBody>
@@ -8531,7 +8531,7 @@
                           </a:solidFill>
                           <a:latin typeface="Arial"/>
                         </a:rPr>
-                        <a:t>43.3% · 86.0 s</a:t>
+                        <a:t>43.3% · 86 s</a:t>
                       </a:r>
                     </a:p>
                   </a:txBody>
@@ -8577,7 +8577,7 @@
                           </a:solidFill>
                           <a:latin typeface="Arial"/>
                         </a:rPr>
-                        <a:t>81.2% · 431.4 s</a:t>
+                        <a:t>81.2% · 431 s</a:t>
                       </a:r>
                     </a:p>
                   </a:txBody>
@@ -8623,7 +8623,7 @@
                           </a:solidFill>
                           <a:latin typeface="Arial"/>
                         </a:rPr>
-                        <a:t>78.0% · 7,191.1 s</a:t>
+                        <a:t>78.0% · 7,191 s</a:t>
                       </a:r>
                     </a:p>
                   </a:txBody>
@@ -8804,7 +8804,7 @@
                 </a:solidFill>
                 <a:latin typeface="Arial"/>
               </a:rPr>
-              <a:t>CNN is best on 50 classes: 81.2% in 431.4 s, about 16.7× faster than tuned XGBoost (78.0%, 7,191.1 s)</a:t>
+              <a:t>CNN is best on 50 classes: 81.2% in 431 s, about 16.7× faster than tuned XGBoost (78.0%, 7,191 s)</a:t>
             </a:r>
           </a:p>
           <a:p>

</xml_diff>